<commit_message>
revisions for writing sample
</commit_message>
<xml_diff>
--- a/Group Project 1/Expansion of the Epidemic Model and Economic Analysis.pptx
+++ b/Group Project 1/Expansion of the Epidemic Model and Economic Analysis.pptx
@@ -211,7 +211,7 @@
           <a:p>
             <a:fld id="{1F07C78D-91C6-46E5-A984-A680DCBF6357}" type="datetimeFigureOut">
               <a:rPr lang="en-US" smtClean="0"/>
-              <a:t>7/14/2025</a:t>
+              <a:t>7/19/25</a:t>
             </a:fld>
             <a:endParaRPr lang="en-US"/>
           </a:p>
@@ -2024,7 +2024,7 @@
           <a:p>
             <a:fld id="{9184DA70-C731-4C70-880D-CCD4705E623C}" type="datetime1">
               <a:rPr lang="en-US" smtClean="0"/>
-              <a:t>7/14/2025</a:t>
+              <a:t>7/19/25</a:t>
             </a:fld>
             <a:endParaRPr lang="en-US" dirty="0"/>
           </a:p>
@@ -2212,7 +2212,7 @@
           <a:p>
             <a:fld id="{B612A279-0833-481D-8C56-F67FD0AC6C50}" type="datetime1">
               <a:rPr lang="en-US" smtClean="0"/>
-              <a:t>7/14/2025</a:t>
+              <a:t>7/19/25</a:t>
             </a:fld>
             <a:endParaRPr lang="en-US" dirty="0"/>
           </a:p>
@@ -2454,7 +2454,7 @@
           <a:p>
             <a:fld id="{6587DA83-5663-4C9C-B9AA-0B40A3DAFF81}" type="datetime1">
               <a:rPr lang="en-US" smtClean="0"/>
-              <a:t>7/14/2025</a:t>
+              <a:t>7/19/25</a:t>
             </a:fld>
             <a:endParaRPr lang="en-US" dirty="0"/>
           </a:p>
@@ -2642,7 +2642,7 @@
           <a:p>
             <a:fld id="{4BE1D723-8F53-4F53-90B0-1982A396982E}" type="datetime1">
               <a:rPr lang="en-US" smtClean="0"/>
-              <a:t>7/14/2025</a:t>
+              <a:t>7/19/25</a:t>
             </a:fld>
             <a:endParaRPr lang="en-US" dirty="0"/>
           </a:p>
@@ -3015,7 +3015,7 @@
           <a:p>
             <a:fld id="{97669AF7-7BEB-44E4-9852-375E34362B5B}" type="datetime1">
               <a:rPr lang="en-US" smtClean="0"/>
-              <a:t>7/14/2025</a:t>
+              <a:t>7/19/25</a:t>
             </a:fld>
             <a:endParaRPr lang="en-US" dirty="0"/>
           </a:p>
@@ -3270,7 +3270,7 @@
           <a:p>
             <a:fld id="{BAAAC38D-0552-4C82-B593-E6124DFADBE2}" type="datetime1">
               <a:rPr lang="en-US" smtClean="0"/>
-              <a:t>7/14/2025</a:t>
+              <a:t>7/19/25</a:t>
             </a:fld>
             <a:endParaRPr lang="en-US" dirty="0"/>
           </a:p>
@@ -3667,7 +3667,7 @@
           <a:p>
             <a:fld id="{D9DF0F1C-5577-4ACB-BB62-DF8F3C494C7E}" type="datetime1">
               <a:rPr lang="en-US" smtClean="0"/>
-              <a:t>7/14/2025</a:t>
+              <a:t>7/19/25</a:t>
             </a:fld>
             <a:endParaRPr lang="en-US" dirty="0"/>
           </a:p>
@@ -3803,7 +3803,7 @@
           <a:p>
             <a:fld id="{1775B394-D9F9-4F0C-B15D-605F45CB9E9F}" type="datetime1">
               <a:rPr lang="en-US" smtClean="0"/>
-              <a:t>7/14/2025</a:t>
+              <a:t>7/19/25</a:t>
             </a:fld>
             <a:endParaRPr lang="en-US" dirty="0"/>
           </a:p>
@@ -3960,7 +3960,7 @@
           <a:p>
             <a:fld id="{39667345-2558-425A-8533-9BFDBCE15005}" type="datetime1">
               <a:rPr lang="en-US" smtClean="0"/>
-              <a:t>7/14/2025</a:t>
+              <a:t>7/19/25</a:t>
             </a:fld>
             <a:endParaRPr lang="en-US" dirty="0"/>
           </a:p>
@@ -4289,7 +4289,7 @@
           <a:p>
             <a:fld id="{92BEA474-078D-4E9B-9B14-09A87B19DC46}" type="datetime1">
               <a:rPr lang="en-US" smtClean="0"/>
-              <a:t>7/14/2025</a:t>
+              <a:t>7/19/25</a:t>
             </a:fld>
             <a:endParaRPr lang="en-US" dirty="0"/>
           </a:p>
@@ -4639,7 +4639,7 @@
           <a:p>
             <a:fld id="{4907D986-8816-4272-A432-0437A28A9828}" type="datetime1">
               <a:rPr lang="en-US" smtClean="0"/>
-              <a:t>7/14/2025</a:t>
+              <a:t>7/19/25</a:t>
             </a:fld>
             <a:endParaRPr lang="en-US" dirty="0"/>
           </a:p>
@@ -4900,7 +4900,7 @@
           <a:p>
             <a:fld id="{62D6E202-B606-4609-B914-27C9371A1F6D}" type="datetime1">
               <a:rPr lang="en-US" smtClean="0"/>
-              <a:t>7/14/2025</a:t>
+              <a:t>7/19/25</a:t>
             </a:fld>
             <a:endParaRPr lang="en-US" dirty="0"/>
           </a:p>
@@ -13615,36 +13615,6 @@
           </a:prstGeom>
         </p:spPr>
       </p:pic>
-      <p:pic>
-        <p:nvPicPr>
-          <p:cNvPr id="1027" name="Picture 1026">
-            <a:extLst>
-              <a:ext uri="{FF2B5EF4-FFF2-40B4-BE49-F238E27FC236}">
-                <a16:creationId xmlns:a16="http://schemas.microsoft.com/office/drawing/2014/main" id="{711B10D4-B71D-9E57-3329-9754837F7EC1}"/>
-              </a:ext>
-            </a:extLst>
-          </p:cNvPr>
-          <p:cNvPicPr>
-            <a:picLocks noChangeAspect="1"/>
-          </p:cNvPicPr>
-          <p:nvPr/>
-        </p:nvPicPr>
-        <p:blipFill>
-          <a:blip r:embed="rId7"/>
-          <a:stretch>
-            <a:fillRect/>
-          </a:stretch>
-        </p:blipFill>
-        <p:spPr>
-          <a:xfrm>
-            <a:off x="7536687" y="2915882"/>
-            <a:ext cx="2556203" cy="433018"/>
-          </a:xfrm>
-          <a:prstGeom prst="rect">
-            <a:avLst/>
-          </a:prstGeom>
-        </p:spPr>
-      </p:pic>
       <p:sp>
         <p:nvSpPr>
           <p:cNvPr id="1028" name="Content Placeholder 2">
@@ -14197,6 +14167,36 @@
           </a:p>
         </p:txBody>
       </p:sp>
+      <p:pic>
+        <p:nvPicPr>
+          <p:cNvPr id="3" name="Picture 2">
+            <a:extLst>
+              <a:ext uri="{FF2B5EF4-FFF2-40B4-BE49-F238E27FC236}">
+                <a16:creationId xmlns:a16="http://schemas.microsoft.com/office/drawing/2014/main" id="{DA2BA35A-27FA-769A-0F9B-8A3C1F3B9899}"/>
+              </a:ext>
+            </a:extLst>
+          </p:cNvPr>
+          <p:cNvPicPr>
+            <a:picLocks noChangeAspect="1"/>
+          </p:cNvPicPr>
+          <p:nvPr/>
+        </p:nvPicPr>
+        <p:blipFill>
+          <a:blip r:embed="rId7"/>
+          <a:stretch>
+            <a:fillRect/>
+          </a:stretch>
+        </p:blipFill>
+        <p:spPr>
+          <a:xfrm>
+            <a:off x="6247285" y="2907246"/>
+            <a:ext cx="5135005" cy="412300"/>
+          </a:xfrm>
+          <a:prstGeom prst="rect">
+            <a:avLst/>
+          </a:prstGeom>
+        </p:spPr>
+      </p:pic>
     </p:spTree>
     <p:extLst>
       <p:ext uri="{BB962C8B-B14F-4D97-AF65-F5344CB8AC3E}">

</xml_diff>